<commit_message>
presentation update, added rotation
</commit_message>
<xml_diff>
--- a/Praesentation.pptx
+++ b/Praesentation.pptx
@@ -18870,8 +18870,8 @@
         </p:nvSpPr>
         <p:spPr>
           <a:xfrm>
-            <a:off x="1550564" y="2331958"/>
-            <a:ext cx="10172044" cy="4379738"/>
+            <a:off x="1550563" y="2331958"/>
+            <a:ext cx="10401291" cy="4379738"/>
           </a:xfrm>
         </p:spPr>
         <p:txBody>
@@ -18884,21 +18884,6 @@
           <a:p>
             <a:pPr rtl="0"/>
             <a:r>
-              <a:rPr lang="de-DE" dirty="0"/>
-              <a:t>Interaktionen mit Canvas und mit 3D </a:t>
-            </a:r>
-            <a:r>
-              <a:rPr lang="de-DE" dirty="0" err="1"/>
-              <a:t>Object</a:t>
-            </a:r>
-            <a:r>
-              <a:rPr lang="de-DE" dirty="0"/>
-              <a:t> Square</a:t>
-            </a:r>
-          </a:p>
-          <a:p>
-            <a:pPr rtl="0"/>
-            <a:r>
               <a:rPr lang="de-DE" b="1" dirty="0"/>
               <a:t>1. 3D </a:t>
             </a:r>
@@ -18990,8 +18975,58 @@
           </a:p>
           <a:p>
             <a:r>
+              <a:rPr lang="de-AT" dirty="0" err="1"/>
+              <a:t>Rigidbody</a:t>
+            </a:r>
+            <a:r>
+              <a:rPr lang="de-AT" dirty="0"/>
+              <a:t> für Rotation in Detailansicht mit </a:t>
+            </a:r>
+            <a:r>
+              <a:rPr lang="de-AT" dirty="0" err="1"/>
+              <a:t>Grabbable</a:t>
+            </a:r>
+            <a:r>
+              <a:rPr lang="de-AT" dirty="0"/>
+              <a:t>, Hand Grab </a:t>
+            </a:r>
+            <a:r>
+              <a:rPr lang="de-AT" dirty="0" err="1"/>
+              <a:t>Interactable</a:t>
+            </a:r>
+            <a:r>
+              <a:rPr lang="de-AT" dirty="0"/>
+              <a:t> und </a:t>
+            </a:r>
+            <a:r>
+              <a:rPr lang="de-AT" dirty="0" err="1"/>
+              <a:t>One</a:t>
+            </a:r>
+            <a:r>
+              <a:rPr lang="de-AT" dirty="0"/>
+              <a:t> Grab </a:t>
+            </a:r>
+            <a:r>
+              <a:rPr lang="de-AT" dirty="0" err="1"/>
+              <a:t>Rotate</a:t>
+            </a:r>
+            <a:r>
+              <a:rPr lang="de-AT" dirty="0"/>
+              <a:t> Transformer</a:t>
+            </a:r>
+          </a:p>
+          <a:p>
+            <a:r>
               <a:rPr lang="de-AT" b="1" dirty="0"/>
-              <a:t>2. Canvas mit Buttons:</a:t>
+              <a:t>2. </a:t>
+            </a:r>
+            <a:r>
+              <a:rPr lang="de-AT" b="1"/>
+              <a:t>UI-Canvas </a:t>
+            </a:r>
+            <a:r>
+              <a:rPr lang="de-AT" b="1" dirty="0"/>
+              <a:t>mit Buttons:</a:t>
             </a:r>
           </a:p>
           <a:p>
@@ -23178,35 +23213,6 @@
 </file>
 
 <file path=customXml/item1.xml><?xml version="1.0" encoding="utf-8"?>
-<p:properties xmlns:p="http://schemas.microsoft.com/office/2006/metadata/properties" xmlns:xsi="http://www.w3.org/2001/XMLSchema-instance" xmlns:pc="http://schemas.microsoft.com/office/infopath/2007/PartnerControls">
-  <documentManagement>
-    <_ip_UnifiedCompliancePolicyUIAction xmlns="http://schemas.microsoft.com/sharepoint/v3" xsi:nil="true"/>
-    <Image xmlns="71af3243-3dd4-4a8d-8c0d-dd76da1f02a5">
-      <Url xsi:nil="true"/>
-      <Description xsi:nil="true"/>
-    </Image>
-    <Status xmlns="71af3243-3dd4-4a8d-8c0d-dd76da1f02a5">Not started</Status>
-    <Background xmlns="71af3243-3dd4-4a8d-8c0d-dd76da1f02a5">false</Background>
-    <_ip_UnifiedCompliancePolicyProperties xmlns="http://schemas.microsoft.com/sharepoint/v3" xsi:nil="true"/>
-    <ImageTagsTaxHTField xmlns="71af3243-3dd4-4a8d-8c0d-dd76da1f02a5">
-      <Terms xmlns="http://schemas.microsoft.com/office/infopath/2007/PartnerControls"/>
-    </ImageTagsTaxHTField>
-    <TaxCatchAll xmlns="230e9df3-be65-4c73-a93b-d1236ebd677e" xsi:nil="true"/>
-    <MediaServiceKeyPoints xmlns="71af3243-3dd4-4a8d-8c0d-dd76da1f02a5" xsi:nil="true"/>
-  </documentManagement>
-</p:properties>
-</file>
-
-<file path=customXml/item2.xml><?xml version="1.0" encoding="utf-8"?>
-<?mso-contentType ?>
-<FormTemplates xmlns="http://schemas.microsoft.com/sharepoint/v3/contenttype/forms">
-  <Display>DocumentLibraryForm</Display>
-  <Edit>DocumentLibraryForm</Edit>
-  <New>DocumentLibraryForm</New>
-</FormTemplates>
-</file>
-
-<file path=customXml/item3.xml><?xml version="1.0" encoding="utf-8"?>
 <ct:contentTypeSchema xmlns:ct="http://schemas.microsoft.com/office/2006/metadata/contentType" xmlns:ma="http://schemas.microsoft.com/office/2006/metadata/properties/metaAttributes" ct:_="" ma:_="" ma:contentTypeName="Document" ma:contentTypeID="0x01010079F111ED35F8CC479449609E8A0923A6" ma:contentTypeVersion="28" ma:contentTypeDescription="Create a new document." ma:contentTypeScope="" ma:versionID="60f5a4f2d2b0abadcf532d48ebf9cb71">
   <xsd:schema xmlns:xsd="http://www.w3.org/2001/XMLSchema" xmlns:xs="http://www.w3.org/2001/XMLSchema" xmlns:p="http://schemas.microsoft.com/office/2006/metadata/properties" xmlns:ns1="http://schemas.microsoft.com/sharepoint/v3" xmlns:ns2="71af3243-3dd4-4a8d-8c0d-dd76da1f02a5" xmlns:ns3="16c05727-aa75-4e4a-9b5f-8a80a1165891" xmlns:ns4="230e9df3-be65-4c73-a93b-d1236ebd677e" targetNamespace="http://schemas.microsoft.com/office/2006/metadata/properties" ma:root="true" ma:fieldsID="7dd78129e6a1811f84807ad11c651531" ns1:_="" ns2:_="" ns3:_="" ns4:_="">
     <xsd:import namespace="http://schemas.microsoft.com/sharepoint/v3"/>
@@ -23518,27 +23524,36 @@
 </ct:contentTypeSchema>
 </file>
 
-<file path=customXml/itemProps1.xml><?xml version="1.0" encoding="utf-8"?>
-<ds:datastoreItem xmlns:ds="http://schemas.openxmlformats.org/officeDocument/2006/customXml" ds:itemID="{BA719FA4-954C-4FA8-82CB-206659C3B826}">
-  <ds:schemaRefs>
-    <ds:schemaRef ds:uri="http://schemas.microsoft.com/office/2006/metadata/properties"/>
-    <ds:schemaRef ds:uri="http://schemas.microsoft.com/office/infopath/2007/PartnerControls"/>
-    <ds:schemaRef ds:uri="http://schemas.microsoft.com/sharepoint/v3"/>
-    <ds:schemaRef ds:uri="71af3243-3dd4-4a8d-8c0d-dd76da1f02a5"/>
-    <ds:schemaRef ds:uri="230e9df3-be65-4c73-a93b-d1236ebd677e"/>
-  </ds:schemaRefs>
-</ds:datastoreItem>
+<file path=customXml/item2.xml><?xml version="1.0" encoding="utf-8"?>
+<?mso-contentType ?>
+<FormTemplates xmlns="http://schemas.microsoft.com/sharepoint/v3/contenttype/forms">
+  <Display>DocumentLibraryForm</Display>
+  <Edit>DocumentLibraryForm</Edit>
+  <New>DocumentLibraryForm</New>
+</FormTemplates>
 </file>
 
-<file path=customXml/itemProps2.xml><?xml version="1.0" encoding="utf-8"?>
-<ds:datastoreItem xmlns:ds="http://schemas.openxmlformats.org/officeDocument/2006/customXml" ds:itemID="{16DBB56F-4362-4386-A1A1-3DF898896616}">
-  <ds:schemaRefs>
-    <ds:schemaRef ds:uri="http://schemas.microsoft.com/sharepoint/v3/contenttype/forms"/>
-  </ds:schemaRefs>
-</ds:datastoreItem>
+<file path=customXml/item3.xml><?xml version="1.0" encoding="utf-8"?>
+<p:properties xmlns:p="http://schemas.microsoft.com/office/2006/metadata/properties" xmlns:xsi="http://www.w3.org/2001/XMLSchema-instance" xmlns:pc="http://schemas.microsoft.com/office/infopath/2007/PartnerControls">
+  <documentManagement>
+    <_ip_UnifiedCompliancePolicyUIAction xmlns="http://schemas.microsoft.com/sharepoint/v3" xsi:nil="true"/>
+    <Image xmlns="71af3243-3dd4-4a8d-8c0d-dd76da1f02a5">
+      <Url xsi:nil="true"/>
+      <Description xsi:nil="true"/>
+    </Image>
+    <Status xmlns="71af3243-3dd4-4a8d-8c0d-dd76da1f02a5">Not started</Status>
+    <Background xmlns="71af3243-3dd4-4a8d-8c0d-dd76da1f02a5">false</Background>
+    <_ip_UnifiedCompliancePolicyProperties xmlns="http://schemas.microsoft.com/sharepoint/v3" xsi:nil="true"/>
+    <ImageTagsTaxHTField xmlns="71af3243-3dd4-4a8d-8c0d-dd76da1f02a5">
+      <Terms xmlns="http://schemas.microsoft.com/office/infopath/2007/PartnerControls"/>
+    </ImageTagsTaxHTField>
+    <TaxCatchAll xmlns="230e9df3-be65-4c73-a93b-d1236ebd677e" xsi:nil="true"/>
+    <MediaServiceKeyPoints xmlns="71af3243-3dd4-4a8d-8c0d-dd76da1f02a5" xsi:nil="true"/>
+  </documentManagement>
+</p:properties>
 </file>
 
-<file path=customXml/itemProps3.xml><?xml version="1.0" encoding="utf-8"?>
+<file path=customXml/itemProps1.xml><?xml version="1.0" encoding="utf-8"?>
 <ds:datastoreItem xmlns:ds="http://schemas.openxmlformats.org/officeDocument/2006/customXml" ds:itemID="{04948363-B267-4BAC-8655-100FBEC280C1}">
   <ds:schemaRefs>
     <ds:schemaRef ds:uri="http://schemas.microsoft.com/office/2006/metadata/contentType"/>
@@ -23559,6 +23574,26 @@
 </ds:datastoreItem>
 </file>
 
+<file path=customXml/itemProps2.xml><?xml version="1.0" encoding="utf-8"?>
+<ds:datastoreItem xmlns:ds="http://schemas.openxmlformats.org/officeDocument/2006/customXml" ds:itemID="{16DBB56F-4362-4386-A1A1-3DF898896616}">
+  <ds:schemaRefs>
+    <ds:schemaRef ds:uri="http://schemas.microsoft.com/sharepoint/v3/contenttype/forms"/>
+  </ds:schemaRefs>
+</ds:datastoreItem>
+</file>
+
+<file path=customXml/itemProps3.xml><?xml version="1.0" encoding="utf-8"?>
+<ds:datastoreItem xmlns:ds="http://schemas.openxmlformats.org/officeDocument/2006/customXml" ds:itemID="{BA719FA4-954C-4FA8-82CB-206659C3B826}">
+  <ds:schemaRefs>
+    <ds:schemaRef ds:uri="http://schemas.microsoft.com/office/2006/metadata/properties"/>
+    <ds:schemaRef ds:uri="http://schemas.microsoft.com/office/infopath/2007/PartnerControls"/>
+    <ds:schemaRef ds:uri="http://schemas.microsoft.com/sharepoint/v3"/>
+    <ds:schemaRef ds:uri="71af3243-3dd4-4a8d-8c0d-dd76da1f02a5"/>
+    <ds:schemaRef ds:uri="230e9df3-be65-4c73-a93b-d1236ebd677e"/>
+  </ds:schemaRefs>
+</ds:datastoreItem>
+</file>
+
 <file path=docMetadata/LabelInfo.xml><?xml version="1.0" encoding="utf-8"?>
 <clbl:labelList xmlns:clbl="http://schemas.microsoft.com/office/2020/mipLabelMetadata">
   <clbl:label id="{a4153a30-97aa-49dd-8839-66f72081522c}" enabled="1" method="Standard" siteId="{9ffff5c3-bdfa-4a9d-b595-ff68329945ef}" contentBits="0" removed="0"/>

</xml_diff>

<commit_message>
finaler commit nach Präsentation
</commit_message>
<xml_diff>
--- a/Praesentation.pptx
+++ b/Praesentation.pptx
@@ -18483,7 +18483,7 @@
         <p:spPr>
           <a:xfrm>
             <a:off x="914400" y="2331791"/>
-            <a:ext cx="9381744" cy="4123873"/>
+            <a:ext cx="10049256" cy="4526209"/>
           </a:xfrm>
         </p:spPr>
         <p:txBody>
@@ -18508,7 +18508,14 @@
           </a:p>
           <a:p>
             <a:pPr rtl="0"/>
-            <a:endParaRPr lang="de-DE" sz="1800" dirty="0"/>
+            <a:r>
+              <a:rPr lang="de-DE" sz="1800" dirty="0" err="1"/>
+              <a:t>JumpToEarth</a:t>
+            </a:r>
+            <a:r>
+              <a:rPr lang="de-DE" sz="1800" dirty="0"/>
+              <a:t>: Holt sich die Koordinaten vom Planeten und stellt uns mit einem Offset dorthin</a:t>
+            </a:r>
           </a:p>
           <a:p>
             <a:pPr rtl="0"/>
@@ -23213,6 +23220,35 @@
 </file>
 
 <file path=customXml/item1.xml><?xml version="1.0" encoding="utf-8"?>
+<p:properties xmlns:p="http://schemas.microsoft.com/office/2006/metadata/properties" xmlns:xsi="http://www.w3.org/2001/XMLSchema-instance" xmlns:pc="http://schemas.microsoft.com/office/infopath/2007/PartnerControls">
+  <documentManagement>
+    <_ip_UnifiedCompliancePolicyUIAction xmlns="http://schemas.microsoft.com/sharepoint/v3" xsi:nil="true"/>
+    <Image xmlns="71af3243-3dd4-4a8d-8c0d-dd76da1f02a5">
+      <Url xsi:nil="true"/>
+      <Description xsi:nil="true"/>
+    </Image>
+    <Status xmlns="71af3243-3dd4-4a8d-8c0d-dd76da1f02a5">Not started</Status>
+    <Background xmlns="71af3243-3dd4-4a8d-8c0d-dd76da1f02a5">false</Background>
+    <_ip_UnifiedCompliancePolicyProperties xmlns="http://schemas.microsoft.com/sharepoint/v3" xsi:nil="true"/>
+    <ImageTagsTaxHTField xmlns="71af3243-3dd4-4a8d-8c0d-dd76da1f02a5">
+      <Terms xmlns="http://schemas.microsoft.com/office/infopath/2007/PartnerControls"/>
+    </ImageTagsTaxHTField>
+    <TaxCatchAll xmlns="230e9df3-be65-4c73-a93b-d1236ebd677e" xsi:nil="true"/>
+    <MediaServiceKeyPoints xmlns="71af3243-3dd4-4a8d-8c0d-dd76da1f02a5" xsi:nil="true"/>
+  </documentManagement>
+</p:properties>
+</file>
+
+<file path=customXml/item2.xml><?xml version="1.0" encoding="utf-8"?>
+<?mso-contentType ?>
+<FormTemplates xmlns="http://schemas.microsoft.com/sharepoint/v3/contenttype/forms">
+  <Display>DocumentLibraryForm</Display>
+  <Edit>DocumentLibraryForm</Edit>
+  <New>DocumentLibraryForm</New>
+</FormTemplates>
+</file>
+
+<file path=customXml/item3.xml><?xml version="1.0" encoding="utf-8"?>
 <ct:contentTypeSchema xmlns:ct="http://schemas.microsoft.com/office/2006/metadata/contentType" xmlns:ma="http://schemas.microsoft.com/office/2006/metadata/properties/metaAttributes" ct:_="" ma:_="" ma:contentTypeName="Document" ma:contentTypeID="0x01010079F111ED35F8CC479449609E8A0923A6" ma:contentTypeVersion="28" ma:contentTypeDescription="Create a new document." ma:contentTypeScope="" ma:versionID="60f5a4f2d2b0abadcf532d48ebf9cb71">
   <xsd:schema xmlns:xsd="http://www.w3.org/2001/XMLSchema" xmlns:xs="http://www.w3.org/2001/XMLSchema" xmlns:p="http://schemas.microsoft.com/office/2006/metadata/properties" xmlns:ns1="http://schemas.microsoft.com/sharepoint/v3" xmlns:ns2="71af3243-3dd4-4a8d-8c0d-dd76da1f02a5" xmlns:ns3="16c05727-aa75-4e4a-9b5f-8a80a1165891" xmlns:ns4="230e9df3-be65-4c73-a93b-d1236ebd677e" targetNamespace="http://schemas.microsoft.com/office/2006/metadata/properties" ma:root="true" ma:fieldsID="7dd78129e6a1811f84807ad11c651531" ns1:_="" ns2:_="" ns3:_="" ns4:_="">
     <xsd:import namespace="http://schemas.microsoft.com/sharepoint/v3"/>
@@ -23524,36 +23560,34 @@
 </ct:contentTypeSchema>
 </file>
 
-<file path=customXml/item2.xml><?xml version="1.0" encoding="utf-8"?>
-<?mso-contentType ?>
-<FormTemplates xmlns="http://schemas.microsoft.com/sharepoint/v3/contenttype/forms">
-  <Display>DocumentLibraryForm</Display>
-  <Edit>DocumentLibraryForm</Edit>
-  <New>DocumentLibraryForm</New>
-</FormTemplates>
+<file path=customXml/itemProps1.xml><?xml version="1.0" encoding="utf-8"?>
+<ds:datastoreItem xmlns:ds="http://schemas.openxmlformats.org/officeDocument/2006/customXml" ds:itemID="{BA719FA4-954C-4FA8-82CB-206659C3B826}">
+  <ds:schemaRefs>
+    <ds:schemaRef ds:uri="http://schemas.microsoft.com/office/2006/documentManagement/types"/>
+    <ds:schemaRef ds:uri="http://purl.org/dc/dcmitype/"/>
+    <ds:schemaRef ds:uri="http://schemas.microsoft.com/office/2006/metadata/properties"/>
+    <ds:schemaRef ds:uri="http://www.w3.org/XML/1998/namespace"/>
+    <ds:schemaRef ds:uri="http://purl.org/dc/terms/"/>
+    <ds:schemaRef ds:uri="http://schemas.microsoft.com/sharepoint/v3"/>
+    <ds:schemaRef ds:uri="16c05727-aa75-4e4a-9b5f-8a80a1165891"/>
+    <ds:schemaRef ds:uri="http://schemas.openxmlformats.org/package/2006/metadata/core-properties"/>
+    <ds:schemaRef ds:uri="http://schemas.microsoft.com/office/infopath/2007/PartnerControls"/>
+    <ds:schemaRef ds:uri="230e9df3-be65-4c73-a93b-d1236ebd677e"/>
+    <ds:schemaRef ds:uri="71af3243-3dd4-4a8d-8c0d-dd76da1f02a5"/>
+    <ds:schemaRef ds:uri="http://purl.org/dc/elements/1.1/"/>
+  </ds:schemaRefs>
+</ds:datastoreItem>
 </file>
 
-<file path=customXml/item3.xml><?xml version="1.0" encoding="utf-8"?>
-<p:properties xmlns:p="http://schemas.microsoft.com/office/2006/metadata/properties" xmlns:xsi="http://www.w3.org/2001/XMLSchema-instance" xmlns:pc="http://schemas.microsoft.com/office/infopath/2007/PartnerControls">
-  <documentManagement>
-    <_ip_UnifiedCompliancePolicyUIAction xmlns="http://schemas.microsoft.com/sharepoint/v3" xsi:nil="true"/>
-    <Image xmlns="71af3243-3dd4-4a8d-8c0d-dd76da1f02a5">
-      <Url xsi:nil="true"/>
-      <Description xsi:nil="true"/>
-    </Image>
-    <Status xmlns="71af3243-3dd4-4a8d-8c0d-dd76da1f02a5">Not started</Status>
-    <Background xmlns="71af3243-3dd4-4a8d-8c0d-dd76da1f02a5">false</Background>
-    <_ip_UnifiedCompliancePolicyProperties xmlns="http://schemas.microsoft.com/sharepoint/v3" xsi:nil="true"/>
-    <ImageTagsTaxHTField xmlns="71af3243-3dd4-4a8d-8c0d-dd76da1f02a5">
-      <Terms xmlns="http://schemas.microsoft.com/office/infopath/2007/PartnerControls"/>
-    </ImageTagsTaxHTField>
-    <TaxCatchAll xmlns="230e9df3-be65-4c73-a93b-d1236ebd677e" xsi:nil="true"/>
-    <MediaServiceKeyPoints xmlns="71af3243-3dd4-4a8d-8c0d-dd76da1f02a5" xsi:nil="true"/>
-  </documentManagement>
-</p:properties>
+<file path=customXml/itemProps2.xml><?xml version="1.0" encoding="utf-8"?>
+<ds:datastoreItem xmlns:ds="http://schemas.openxmlformats.org/officeDocument/2006/customXml" ds:itemID="{16DBB56F-4362-4386-A1A1-3DF898896616}">
+  <ds:schemaRefs>
+    <ds:schemaRef ds:uri="http://schemas.microsoft.com/sharepoint/v3/contenttype/forms"/>
+  </ds:schemaRefs>
+</ds:datastoreItem>
 </file>
 
-<file path=customXml/itemProps1.xml><?xml version="1.0" encoding="utf-8"?>
+<file path=customXml/itemProps3.xml><?xml version="1.0" encoding="utf-8"?>
 <ds:datastoreItem xmlns:ds="http://schemas.openxmlformats.org/officeDocument/2006/customXml" ds:itemID="{04948363-B267-4BAC-8655-100FBEC280C1}">
   <ds:schemaRefs>
     <ds:schemaRef ds:uri="http://schemas.microsoft.com/office/2006/metadata/contentType"/>
@@ -23574,26 +23608,6 @@
 </ds:datastoreItem>
 </file>
 
-<file path=customXml/itemProps2.xml><?xml version="1.0" encoding="utf-8"?>
-<ds:datastoreItem xmlns:ds="http://schemas.openxmlformats.org/officeDocument/2006/customXml" ds:itemID="{16DBB56F-4362-4386-A1A1-3DF898896616}">
-  <ds:schemaRefs>
-    <ds:schemaRef ds:uri="http://schemas.microsoft.com/sharepoint/v3/contenttype/forms"/>
-  </ds:schemaRefs>
-</ds:datastoreItem>
-</file>
-
-<file path=customXml/itemProps3.xml><?xml version="1.0" encoding="utf-8"?>
-<ds:datastoreItem xmlns:ds="http://schemas.openxmlformats.org/officeDocument/2006/customXml" ds:itemID="{BA719FA4-954C-4FA8-82CB-206659C3B826}">
-  <ds:schemaRefs>
-    <ds:schemaRef ds:uri="http://schemas.microsoft.com/office/2006/metadata/properties"/>
-    <ds:schemaRef ds:uri="http://schemas.microsoft.com/office/infopath/2007/PartnerControls"/>
-    <ds:schemaRef ds:uri="http://schemas.microsoft.com/sharepoint/v3"/>
-    <ds:schemaRef ds:uri="71af3243-3dd4-4a8d-8c0d-dd76da1f02a5"/>
-    <ds:schemaRef ds:uri="230e9df3-be65-4c73-a93b-d1236ebd677e"/>
-  </ds:schemaRefs>
-</ds:datastoreItem>
-</file>
-
 <file path=docMetadata/LabelInfo.xml><?xml version="1.0" encoding="utf-8"?>
 <clbl:labelList xmlns:clbl="http://schemas.microsoft.com/office/2020/mipLabelMetadata">
   <clbl:label id="{a4153a30-97aa-49dd-8839-66f72081522c}" enabled="1" method="Standard" siteId="{9ffff5c3-bdfa-4a9d-b595-ff68329945ef}" contentBits="0" removed="0"/>

</xml_diff>